<commit_message>
Redesign Light template warm amber tint - remove unused templates - 730 tests
</commit_message>
<xml_diff>
--- a/templates/meta-ads-light.pptx
+++ b/templates/meta-ads-light.pptx
@@ -3287,7 +3287,7 @@
             <a:r>
               <a:rPr b="1" i="0" lang="en-US" sz="6000" u="none" cap="none" strike="noStrike">
                 <a:solidFill>
-                  <a:schemeClr val="lt1"/>
+                  <a:srgbClr val="F6AD55"/>
                 </a:solidFill>
                 <a:latin typeface="Poppins"/>
                 <a:ea typeface="Poppins"/>
@@ -3311,7 +3311,7 @@
             <a:r>
               <a:rPr b="1" i="0" lang="en-US" sz="6000" u="none" cap="none" strike="noStrike">
                 <a:solidFill>
-                  <a:schemeClr val="lt1"/>
+                  <a:srgbClr val="F6AD55"/>
                 </a:solidFill>
                 <a:latin typeface="Poppins"/>
                 <a:ea typeface="Poppins"/>
@@ -3781,8 +3781,10 @@
             <a:solidFill>
               <a:schemeClr val="accent5"/>
             </a:solidFill>
-            <a:ln>
-              <a:noFill/>
+            <a:ln w="9525">
+              <a:solidFill>
+                <a:srgbClr val="F0D9B5"/>
+              </a:solidFill>
             </a:ln>
             <a:effectLst>
               <a:outerShdw blurRad="190500" sx="99000" rotWithShape="0" algn="t" dir="5400000" dist="63500" sy="99000">
@@ -4174,8 +4176,10 @@
             <a:solidFill>
               <a:schemeClr val="accent5"/>
             </a:solidFill>
-            <a:ln>
-              <a:noFill/>
+            <a:ln w="9525">
+              <a:solidFill>
+                <a:srgbClr val="F0D9B5"/>
+              </a:solidFill>
             </a:ln>
             <a:effectLst>
               <a:outerShdw blurRad="190500" sx="99000" rotWithShape="0" algn="t" dir="5400000" dist="63500" sy="99000">
@@ -4567,8 +4571,10 @@
             <a:solidFill>
               <a:schemeClr val="accent5"/>
             </a:solidFill>
-            <a:ln>
-              <a:noFill/>
+            <a:ln w="9525">
+              <a:solidFill>
+                <a:srgbClr val="F0D9B5"/>
+              </a:solidFill>
             </a:ln>
             <a:effectLst>
               <a:outerShdw blurRad="190500" sx="99000" rotWithShape="0" algn="t" dir="5400000" dist="63500" sy="99000">
@@ -4960,8 +4966,10 @@
             <a:solidFill>
               <a:schemeClr val="accent5"/>
             </a:solidFill>
-            <a:ln>
-              <a:noFill/>
+            <a:ln w="9525">
+              <a:solidFill>
+                <a:srgbClr val="F0D9B5"/>
+              </a:solidFill>
             </a:ln>
             <a:effectLst>
               <a:outerShdw blurRad="190500" sx="99000" rotWithShape="0" algn="t" dir="5400000" dist="63500" sy="99000">
@@ -5339,8 +5347,10 @@
           <a:solidFill>
             <a:schemeClr val="accent5"/>
           </a:solidFill>
-          <a:ln>
-            <a:noFill/>
+          <a:ln w="9525">
+            <a:solidFill>
+              <a:srgbClr val="F0D9B5"/>
+            </a:solidFill>
           </a:ln>
           <a:effectLst>
             <a:outerShdw blurRad="190500" sx="99000" rotWithShape="0" algn="t" dir="5400000" dist="63500" sy="99000">
@@ -5717,8 +5727,10 @@
           <a:solidFill>
             <a:schemeClr val="accent5"/>
           </a:solidFill>
-          <a:ln>
-            <a:noFill/>
+          <a:ln w="9525">
+            <a:solidFill>
+              <a:srgbClr val="F0D9B5"/>
+            </a:solidFill>
           </a:ln>
           <a:effectLst>
             <a:outerShdw blurRad="190500" sx="99000" rotWithShape="0" algn="t" dir="5400000" dist="63500" sy="99000">
@@ -6095,8 +6107,10 @@
           <a:solidFill>
             <a:schemeClr val="accent5"/>
           </a:solidFill>
-          <a:ln>
-            <a:noFill/>
+          <a:ln w="9525">
+            <a:solidFill>
+              <a:srgbClr val="F0D9B5"/>
+            </a:solidFill>
           </a:ln>
           <a:effectLst>
             <a:outerShdw blurRad="190500" sx="99000" rotWithShape="0" algn="t" dir="5400000" dist="63500" sy="99000">
@@ -7088,7 +7102,7 @@
             <a:r>
               <a:rPr b="0" i="0" lang="en-US" sz="2800" u="none" cap="none" strike="noStrike">
                 <a:solidFill>
-                  <a:srgbClr val="0D1B2E"/>
+                  <a:srgbClr val="C17D0A"/>
                 </a:solidFill>
                 <a:latin typeface="Poppins SemiBold"/>
                 <a:ea typeface="Poppins SemiBold"/>
@@ -7394,7 +7408,7 @@
                   <a:tcPr marT="0" marB="0" marR="63500" marL="63500" anchor="ctr">
                     <a:lnR cap="flat" cmpd="sng" w="19050">
                       <a:solidFill>
-                        <a:srgbClr val="E2E8F0"/>
+                        <a:srgbClr val="F0D9B5"/>
                       </a:solidFill>
                       <a:prstDash val="solid"/>
                       <a:round/>
@@ -7465,7 +7479,7 @@
                   <a:tcPr marT="0" marB="0" marR="63500" marL="63500" anchor="ctr">
                     <a:lnL cap="flat" cmpd="sng" w="19050">
                       <a:solidFill>
-                        <a:srgbClr val="E2E8F0"/>
+                        <a:srgbClr val="F0D9B5"/>
                       </a:solidFill>
                       <a:prstDash val="solid"/>
                       <a:round/>
@@ -7474,7 +7488,7 @@
                     </a:lnL>
                     <a:lnR cap="flat" cmpd="sng" w="19050">
                       <a:solidFill>
-                        <a:srgbClr val="E2E8F0"/>
+                        <a:srgbClr val="F0D9B5"/>
                       </a:solidFill>
                       <a:prstDash val="solid"/>
                       <a:round/>
@@ -7545,7 +7559,7 @@
                   <a:tcPr marT="0" marB="0" marR="63500" marL="63500" anchor="ctr">
                     <a:lnL cap="flat" cmpd="sng" w="19050">
                       <a:solidFill>
-                        <a:srgbClr val="E2E8F0"/>
+                        <a:srgbClr val="F0D9B5"/>
                       </a:solidFill>
                       <a:prstDash val="solid"/>
                       <a:round/>
@@ -7554,7 +7568,7 @@
                     </a:lnL>
                     <a:lnR cap="flat" cmpd="sng" w="19050">
                       <a:solidFill>
-                        <a:srgbClr val="E2E8F0"/>
+                        <a:srgbClr val="F0D9B5"/>
                       </a:solidFill>
                       <a:prstDash val="solid"/>
                       <a:round/>
@@ -7625,7 +7639,7 @@
                   <a:tcPr marT="0" marB="0" marR="63500" marL="63500" anchor="ctr">
                     <a:lnL cap="flat" cmpd="sng" w="19050">
                       <a:solidFill>
-                        <a:srgbClr val="E2E8F0"/>
+                        <a:srgbClr val="F0D9B5"/>
                       </a:solidFill>
                       <a:prstDash val="solid"/>
                       <a:round/>
@@ -7634,7 +7648,7 @@
                     </a:lnL>
                     <a:lnR cap="flat" cmpd="sng" w="19050">
                       <a:solidFill>
-                        <a:srgbClr val="E2E8F0"/>
+                        <a:srgbClr val="F0D9B5"/>
                       </a:solidFill>
                       <a:prstDash val="solid"/>
                       <a:round/>
@@ -7705,7 +7719,7 @@
                   <a:tcPr marT="0" marB="0" marR="63500" marL="63500" anchor="ctr">
                     <a:lnL cap="flat" cmpd="sng" w="19050">
                       <a:solidFill>
-                        <a:srgbClr val="E2E8F0"/>
+                        <a:srgbClr val="F0D9B5"/>
                       </a:solidFill>
                       <a:prstDash val="solid"/>
                       <a:round/>
@@ -7714,7 +7728,7 @@
                     </a:lnL>
                     <a:lnR cap="flat" cmpd="sng" w="19050">
                       <a:solidFill>
-                        <a:srgbClr val="E2E8F0"/>
+                        <a:srgbClr val="F0D9B5"/>
                       </a:solidFill>
                       <a:prstDash val="solid"/>
                       <a:round/>
@@ -7785,7 +7799,7 @@
                   <a:tcPr marT="0" marB="0" marR="63500" marL="63500" anchor="ctr">
                     <a:lnL cap="flat" cmpd="sng" w="19050">
                       <a:solidFill>
-                        <a:srgbClr val="E2E8F0"/>
+                        <a:srgbClr val="F0D9B5"/>
                       </a:solidFill>
                       <a:prstDash val="solid"/>
                       <a:round/>
@@ -7794,7 +7808,7 @@
                     </a:lnL>
                     <a:lnR cap="flat" cmpd="sng" w="19050">
                       <a:solidFill>
-                        <a:srgbClr val="E2E8F0"/>
+                        <a:srgbClr val="F0D9B5"/>
                       </a:solidFill>
                       <a:prstDash val="solid"/>
                       <a:round/>
@@ -7865,7 +7879,7 @@
                   <a:tcPr marT="0" marB="0" marR="63500" marL="63500" anchor="ctr">
                     <a:lnL cap="flat" cmpd="sng" w="19050">
                       <a:solidFill>
-                        <a:srgbClr val="E2E8F0"/>
+                        <a:srgbClr val="F0D9B5"/>
                       </a:solidFill>
                       <a:prstDash val="solid"/>
                       <a:round/>
@@ -7874,7 +7888,7 @@
                     </a:lnL>
                     <a:lnR cap="flat" cmpd="sng" w="19050">
                       <a:solidFill>
-                        <a:srgbClr val="E2E8F0"/>
+                        <a:srgbClr val="F0D9B5"/>
                       </a:solidFill>
                       <a:prstDash val="solid"/>
                       <a:round/>
@@ -7945,7 +7959,7 @@
                   <a:tcPr marT="0" marB="0" marR="63500" marL="63500" anchor="ctr">
                     <a:lnL cap="flat" cmpd="sng" w="19050">
                       <a:solidFill>
-                        <a:srgbClr val="E2E8F0"/>
+                        <a:srgbClr val="F0D9B5"/>
                       </a:solidFill>
                       <a:prstDash val="solid"/>
                       <a:round/>
@@ -7954,7 +7968,7 @@
                     </a:lnL>
                     <a:lnR cap="flat" cmpd="sng" w="19050">
                       <a:solidFill>
-                        <a:srgbClr val="E2E8F0"/>
+                        <a:srgbClr val="F0D9B5"/>
                       </a:solidFill>
                       <a:prstDash val="solid"/>
                       <a:round/>
@@ -8025,7 +8039,7 @@
                   <a:tcPr marT="0" marB="0" marR="63500" marL="63500" anchor="ctr">
                     <a:lnL cap="flat" cmpd="sng" w="19050">
                       <a:solidFill>
-                        <a:srgbClr val="E2E8F0"/>
+                        <a:srgbClr val="F0D9B5"/>
                       </a:solidFill>
                       <a:prstDash val="solid"/>
                       <a:round/>
@@ -8034,7 +8048,7 @@
                     </a:lnL>
                     <a:lnR cap="flat" cmpd="sng" w="19050">
                       <a:solidFill>
-                        <a:srgbClr val="E2E8F0"/>
+                        <a:srgbClr val="F0D9B5"/>
                       </a:solidFill>
                       <a:prstDash val="solid"/>
                       <a:round/>
@@ -8105,7 +8119,7 @@
                   <a:tcPr marT="0" marB="0" marR="63500" marL="63500" anchor="ctr">
                     <a:lnL cap="flat" cmpd="sng" w="19050">
                       <a:solidFill>
-                        <a:srgbClr val="E2E8F0"/>
+                        <a:srgbClr val="F0D9B5"/>
                       </a:solidFill>
                       <a:prstDash val="solid"/>
                       <a:round/>
@@ -8114,7 +8128,7 @@
                     </a:lnL>
                     <a:lnR cap="flat" cmpd="sng" w="19050">
                       <a:solidFill>
-                        <a:srgbClr val="E2E8F0"/>
+                        <a:srgbClr val="F0D9B5"/>
                       </a:solidFill>
                       <a:prstDash val="solid"/>
                       <a:round/>
@@ -10091,7 +10105,7 @@
             <a:r>
               <a:rPr b="0" i="0" lang="en-US" sz="4000" u="none" cap="none" strike="noStrike">
                 <a:solidFill>
-                  <a:srgbClr val="0D1B2E"/>
+                  <a:srgbClr val="C17D0A"/>
                 </a:solidFill>
                 <a:latin typeface="Poppins SemiBold"/>
                 <a:ea typeface="Poppins SemiBold"/>
@@ -10182,7 +10196,7 @@
             <a:r>
               <a:rPr b="0" i="0" lang="en-US" sz="4000" u="none" cap="none" strike="noStrike">
                 <a:solidFill>
-                  <a:schemeClr val="lt1"/>
+                  <a:srgbClr val="C17D0A"/>
                 </a:solidFill>
                 <a:latin typeface="Poppins SemiBold"/>
                 <a:ea typeface="Poppins SemiBold"/>
@@ -10264,8 +10278,10 @@
                 <a:solidFill>
                   <a:schemeClr val="accent5"/>
                 </a:solidFill>
-                <a:ln>
-                  <a:noFill/>
+                <a:ln w="9525">
+                  <a:solidFill>
+                    <a:srgbClr val="F0D9B5"/>
+                  </a:solidFill>
                 </a:ln>
                 <a:effectLst>
                   <a:outerShdw blurRad="190500" sx="99000" rotWithShape="0" algn="t" dir="5400000" dist="63500" sy="99000">
@@ -10642,8 +10658,10 @@
                 <a:solidFill>
                   <a:schemeClr val="accent5"/>
                 </a:solidFill>
-                <a:ln>
-                  <a:noFill/>
+                <a:ln w="9525">
+                  <a:solidFill>
+                    <a:srgbClr val="F0D9B5"/>
+                  </a:solidFill>
                 </a:ln>
                 <a:effectLst>
                   <a:outerShdw blurRad="190500" sx="99000" rotWithShape="0" algn="t" dir="5400000" dist="63500" sy="99000">
@@ -11020,8 +11038,10 @@
                 <a:solidFill>
                   <a:schemeClr val="accent5"/>
                 </a:solidFill>
-                <a:ln>
-                  <a:noFill/>
+                <a:ln w="9525">
+                  <a:solidFill>
+                    <a:srgbClr val="F0D9B5"/>
+                  </a:solidFill>
                 </a:ln>
                 <a:effectLst>
                   <a:outerShdw blurRad="190500" sx="99000" rotWithShape="0" algn="t" dir="5400000" dist="63500" sy="99000">
@@ -11425,8 +11445,10 @@
                 <a:solidFill>
                   <a:schemeClr val="accent5"/>
                 </a:solidFill>
-                <a:ln>
-                  <a:noFill/>
+                <a:ln w="9525">
+                  <a:solidFill>
+                    <a:srgbClr val="F0D9B5"/>
+                  </a:solidFill>
                 </a:ln>
                 <a:effectLst>
                   <a:outerShdw blurRad="190500" sx="99000" rotWithShape="0" algn="t" dir="5400000" dist="63500" sy="99000">
@@ -11803,8 +11825,10 @@
                 <a:solidFill>
                   <a:schemeClr val="accent5"/>
                 </a:solidFill>
-                <a:ln>
-                  <a:noFill/>
+                <a:ln w="9525">
+                  <a:solidFill>
+                    <a:srgbClr val="F0D9B5"/>
+                  </a:solidFill>
                 </a:ln>
                 <a:effectLst>
                   <a:outerShdw blurRad="190500" sx="99000" rotWithShape="0" algn="t" dir="5400000" dist="63500" sy="99000">
@@ -12181,8 +12205,10 @@
                 <a:solidFill>
                   <a:schemeClr val="accent5"/>
                 </a:solidFill>
-                <a:ln>
-                  <a:noFill/>
+                <a:ln w="9525">
+                  <a:solidFill>
+                    <a:srgbClr val="F0D9B5"/>
+                  </a:solidFill>
                 </a:ln>
                 <a:effectLst>
                   <a:outerShdw blurRad="190500" sx="99000" rotWithShape="0" algn="t" dir="5400000" dist="63500" sy="99000">
@@ -12586,8 +12612,10 @@
                 <a:solidFill>
                   <a:schemeClr val="accent5"/>
                 </a:solidFill>
-                <a:ln>
-                  <a:noFill/>
+                <a:ln w="9525">
+                  <a:solidFill>
+                    <a:srgbClr val="F0D9B5"/>
+                  </a:solidFill>
                 </a:ln>
                 <a:effectLst>
                   <a:outerShdw blurRad="190500" sx="99000" rotWithShape="0" algn="t" dir="5400000" dist="63500" sy="99000">
@@ -12964,8 +12992,10 @@
                 <a:solidFill>
                   <a:schemeClr val="accent5"/>
                 </a:solidFill>
-                <a:ln>
-                  <a:noFill/>
+                <a:ln w="9525">
+                  <a:solidFill>
+                    <a:srgbClr val="F0D9B5"/>
+                  </a:solidFill>
                 </a:ln>
                 <a:effectLst>
                   <a:outerShdw blurRad="190500" sx="99000" rotWithShape="0" algn="t" dir="5400000" dist="63500" sy="99000">
@@ -13354,8 +13384,10 @@
                 <a:solidFill>
                   <a:schemeClr val="accent5"/>
                 </a:solidFill>
-                <a:ln>
-                  <a:noFill/>
+                <a:ln w="9525">
+                  <a:solidFill>
+                    <a:srgbClr val="F0D9B5"/>
+                  </a:solidFill>
                 </a:ln>
                 <a:effectLst>
                   <a:outerShdw blurRad="190500" sx="99000" rotWithShape="0" algn="t" dir="5400000" dist="63500" sy="99000">
@@ -13747,8 +13779,10 @@
                 <a:solidFill>
                   <a:schemeClr val="accent5"/>
                 </a:solidFill>
-                <a:ln>
-                  <a:noFill/>
+                <a:ln w="9525">
+                  <a:solidFill>
+                    <a:srgbClr val="F0D9B5"/>
+                  </a:solidFill>
                 </a:ln>
                 <a:effectLst>
                   <a:outerShdw blurRad="190500" sx="99000" rotWithShape="0" algn="t" dir="5400000" dist="63500" sy="99000">
@@ -14137,8 +14171,10 @@
                 <a:solidFill>
                   <a:schemeClr val="accent5"/>
                 </a:solidFill>
-                <a:ln>
-                  <a:noFill/>
+                <a:ln w="9525">
+                  <a:solidFill>
+                    <a:srgbClr val="F0D9B5"/>
+                  </a:solidFill>
                 </a:ln>
                 <a:effectLst>
                   <a:outerShdw blurRad="190500" sx="99000" rotWithShape="0" algn="t" dir="5400000" dist="63500" sy="99000">
@@ -14527,8 +14563,10 @@
                 <a:solidFill>
                   <a:schemeClr val="accent5"/>
                 </a:solidFill>
-                <a:ln>
-                  <a:noFill/>
+                <a:ln w="9525">
+                  <a:solidFill>
+                    <a:srgbClr val="F0D9B5"/>
+                  </a:solidFill>
                 </a:ln>
                 <a:effectLst>
                   <a:outerShdw blurRad="190500" sx="99000" rotWithShape="0" algn="t" dir="5400000" dist="63500" sy="99000">
@@ -15172,10 +15210,10 @@
         <a:srgbClr val="0D1B2E"/>
       </a:lt1>
       <a:dk2>
-        <a:srgbClr val="475569"/>
+        <a:srgbClr val="4A5568"/>
       </a:dk2>
       <a:lt2>
-        <a:srgbClr val="F1F5F9"/>
+        <a:srgbClr val="FFFFFF"/>
       </a:lt2>
       <a:accent1>
         <a:srgbClr val="FF3200"/>
@@ -15190,10 +15228,10 @@
         <a:srgbClr val="016ED9"/>
       </a:accent4>
       <a:accent5>
-        <a:srgbClr val="F1F5F9"/>
+        <a:srgbClr val="FFFFFF"/>
       </a:accent5>
       <a:accent6>
-        <a:srgbClr val="FFFFFF"/>
+        <a:srgbClr val="FDF6EC"/>
       </a:accent6>
       <a:hlink>
         <a:srgbClr val="0563C1"/>

</xml_diff>

<commit_message>
Fix Light template text readability - all text dark navy - 730 tests
</commit_message>
<xml_diff>
--- a/templates/meta-ads-light.pptx
+++ b/templates/meta-ads-light.pptx
@@ -3596,7 +3596,7 @@
             <a:r>
               <a:rPr b="0" i="0" lang="en-US" sz="1200" u="none" cap="none" strike="noStrike">
                 <a:solidFill>
-                  <a:srgbClr val="BFBFBF"/>
+                  <a:srgbClr val="0D1B2E"/>
                 </a:solidFill>
                 <a:latin typeface="Open Sans"/>
                 <a:ea typeface="Open Sans"/>
@@ -3607,7 +3607,7 @@
             </a:r>
             <a:endParaRPr b="0" i="0" sz="1200" u="none" cap="none" strike="noStrike">
               <a:solidFill>
-                <a:srgbClr val="BFBFBF"/>
+                <a:srgbClr val="0D1B2E"/>
               </a:solidFill>
               <a:latin typeface="Open Sans"/>
               <a:ea typeface="Open Sans"/>
@@ -3657,7 +3657,7 @@
             <a:r>
               <a:rPr b="1" i="0" lang="en-US" sz="1100" u="none" cap="none" strike="noStrike">
                 <a:solidFill>
-                  <a:srgbClr val="A0D2A0"/>
+                  <a:srgbClr val="0D1B2E"/>
                 </a:solidFill>
                 <a:latin typeface="Arial"/>
                 <a:ea typeface="Arial"/>
@@ -3710,7 +3710,7 @@
             <a:r>
               <a:rPr b="0" i="0" lang="en-US" sz="1200" u="none" cap="none" strike="noStrike">
                 <a:solidFill>
-                  <a:srgbClr val="A0B9D2"/>
+                  <a:srgbClr val="0D1B2E"/>
                 </a:solidFill>
                 <a:latin typeface="Arial"/>
                 <a:ea typeface="Arial"/>
@@ -4054,7 +4054,7 @@
                 <a:r>
                   <a:rPr b="0" i="0" lang="en-US" sz="1150" u="none" cap="none" strike="noStrike">
                     <a:solidFill>
-                      <a:srgbClr val="64748B"/>
+                      <a:srgbClr val="1E3A5F"/>
                     </a:solidFill>
                     <a:latin typeface="Poppins Medium"/>
                     <a:ea typeface="Poppins Medium"/>
@@ -4449,7 +4449,7 @@
                 <a:r>
                   <a:rPr b="0" i="0" lang="en-US" sz="1150" u="none" cap="none" strike="noStrike">
                     <a:solidFill>
-                      <a:srgbClr val="64748B"/>
+                      <a:srgbClr val="1E3A5F"/>
                     </a:solidFill>
                     <a:latin typeface="Poppins Medium"/>
                     <a:ea typeface="Poppins Medium"/>
@@ -4844,7 +4844,7 @@
                 <a:r>
                   <a:rPr b="0" i="0" lang="en-US" sz="1150" u="none" cap="none" strike="noStrike">
                     <a:solidFill>
-                      <a:srgbClr val="64748B"/>
+                      <a:srgbClr val="1E3A5F"/>
                     </a:solidFill>
                     <a:latin typeface="Poppins Medium"/>
                     <a:ea typeface="Poppins Medium"/>
@@ -5239,7 +5239,7 @@
                 <a:r>
                   <a:rPr b="0" i="0" lang="en-US" sz="1150" u="none" cap="none" strike="noStrike">
                     <a:solidFill>
-                      <a:srgbClr val="64748B"/>
+                      <a:srgbClr val="1E3A5F"/>
                     </a:solidFill>
                     <a:latin typeface="Poppins Medium"/>
                     <a:ea typeface="Poppins Medium"/>
@@ -5620,7 +5620,7 @@
               <a:r>
                 <a:rPr b="0" i="0" lang="en-US" sz="1150" u="none" cap="none" strike="noStrike">
                   <a:solidFill>
-                    <a:srgbClr val="64748B"/>
+                    <a:srgbClr val="1E3A5F"/>
                   </a:solidFill>
                   <a:latin typeface="Poppins Medium"/>
                   <a:ea typeface="Poppins Medium"/>
@@ -6000,7 +6000,7 @@
               <a:r>
                 <a:rPr b="0" i="0" lang="en-US" sz="1150" u="none" cap="none" strike="noStrike">
                   <a:solidFill>
-                    <a:srgbClr val="64748B"/>
+                    <a:srgbClr val="1E3A5F"/>
                   </a:solidFill>
                   <a:latin typeface="Poppins Medium"/>
                   <a:ea typeface="Poppins Medium"/>
@@ -6380,7 +6380,7 @@
               <a:r>
                 <a:rPr b="0" i="0" lang="en-US" sz="1150" u="none" cap="none" strike="noStrike">
                   <a:solidFill>
-                    <a:srgbClr val="64748B"/>
+                    <a:srgbClr val="1E3A5F"/>
                   </a:solidFill>
                   <a:latin typeface="Poppins Medium"/>
                   <a:ea typeface="Poppins Medium"/>
@@ -6659,7 +6659,7 @@
                 </a:r>
                 <a:endParaRPr b="0" i="0" sz="1300" u="none" cap="none" strike="noStrike">
                   <a:solidFill>
-                    <a:srgbClr val="BFBFBF"/>
+                    <a:srgbClr val="0D1B2E"/>
                   </a:solidFill>
                   <a:latin typeface="Open Sans"/>
                   <a:ea typeface="Open Sans"/>
@@ -7005,7 +7005,7 @@
             <a:r>
               <a:rPr b="0" i="0" lang="en-US" sz="1300" u="none" cap="none" strike="noStrike">
                 <a:solidFill>
-                  <a:srgbClr val="BFBFBF"/>
+                  <a:srgbClr val="0D1B2E"/>
                 </a:solidFill>
                 <a:latin typeface="Open Sans"/>
                 <a:ea typeface="Open Sans"/>
@@ -7016,7 +7016,7 @@
             </a:r>
             <a:endParaRPr b="0" i="0" sz="1300" u="none" cap="none" strike="noStrike">
               <a:solidFill>
-                <a:srgbClr val="BFBFBF"/>
+                <a:srgbClr val="0D1B2E"/>
               </a:solidFill>
               <a:latin typeface="Open Sans"/>
               <a:ea typeface="Open Sans"/>
@@ -7047,7 +7047,7 @@
             </a:r>
             <a:endParaRPr b="0" i="0" sz="1300" u="none" cap="none" strike="noStrike">
               <a:solidFill>
-                <a:srgbClr val="BFBFBF"/>
+                <a:srgbClr val="0D1B2E"/>
               </a:solidFill>
               <a:latin typeface="Open Sans"/>
               <a:ea typeface="Open Sans"/>
@@ -10603,7 +10603,7 @@
                   <a:r>
                     <a:rPr b="0" i="0" lang="en-US" sz="900" u="none" cap="none" strike="noStrike">
                       <a:solidFill>
-                        <a:srgbClr val="BFBFBF"/>
+                        <a:srgbClr val="0D1B2E"/>
                       </a:solidFill>
                       <a:latin typeface="Poppins"/>
                       <a:ea typeface="Poppins"/>
@@ -10983,7 +10983,7 @@
                   <a:r>
                     <a:rPr b="0" i="0" lang="en-US" sz="900" u="none" cap="none" strike="noStrike">
                       <a:solidFill>
-                        <a:srgbClr val="BFBFBF"/>
+                        <a:srgbClr val="0D1B2E"/>
                       </a:solidFill>
                       <a:latin typeface="Poppins"/>
                       <a:ea typeface="Poppins"/>
@@ -11375,7 +11375,7 @@
                   <a:r>
                     <a:rPr b="0" i="0" lang="en-US" sz="900" u="none" cap="none" strike="noStrike">
                       <a:solidFill>
-                        <a:srgbClr val="BFBFBF"/>
+                        <a:srgbClr val="0D1B2E"/>
                       </a:solidFill>
                       <a:latin typeface="Poppins"/>
                       <a:ea typeface="Poppins"/>
@@ -11770,7 +11770,7 @@
                   <a:r>
                     <a:rPr b="0" i="0" lang="en-US" sz="900" u="none" cap="none" strike="noStrike">
                       <a:solidFill>
-                        <a:srgbClr val="BFBFBF"/>
+                        <a:srgbClr val="0D1B2E"/>
                       </a:solidFill>
                       <a:latin typeface="Poppins"/>
                       <a:ea typeface="Poppins"/>
@@ -12150,7 +12150,7 @@
                   <a:r>
                     <a:rPr b="0" i="0" lang="en-US" sz="900" u="none" cap="none" strike="noStrike">
                       <a:solidFill>
-                        <a:srgbClr val="BFBFBF"/>
+                        <a:srgbClr val="0D1B2E"/>
                       </a:solidFill>
                       <a:latin typeface="Poppins"/>
                       <a:ea typeface="Poppins"/>
@@ -12542,7 +12542,7 @@
                   <a:r>
                     <a:rPr b="0" i="0" lang="en-US" sz="900" u="none" cap="none" strike="noStrike">
                       <a:solidFill>
-                        <a:srgbClr val="BFBFBF"/>
+                        <a:srgbClr val="0D1B2E"/>
                       </a:solidFill>
                       <a:latin typeface="Poppins"/>
                       <a:ea typeface="Poppins"/>
@@ -12937,7 +12937,7 @@
                   <a:r>
                     <a:rPr b="0" i="0" lang="en-US" sz="900" u="none" cap="none" strike="noStrike">
                       <a:solidFill>
-                        <a:srgbClr val="BFBFBF"/>
+                        <a:srgbClr val="0D1B2E"/>
                       </a:solidFill>
                       <a:latin typeface="Poppins"/>
                       <a:ea typeface="Poppins"/>
@@ -13329,7 +13329,7 @@
                   <a:r>
                     <a:rPr b="0" i="0" lang="en-US" sz="900" u="none" cap="none" strike="noStrike">
                       <a:solidFill>
-                        <a:srgbClr val="BFBFBF"/>
+                        <a:srgbClr val="0D1B2E"/>
                       </a:solidFill>
                       <a:latin typeface="Poppins"/>
                       <a:ea typeface="Poppins"/>
@@ -13709,7 +13709,7 @@
                   <a:r>
                     <a:rPr b="0" i="0" lang="en-US" sz="900" u="none" cap="none" strike="noStrike">
                       <a:solidFill>
-                        <a:srgbClr val="BFBFBF"/>
+                        <a:srgbClr val="0D1B2E"/>
                       </a:solidFill>
                       <a:latin typeface="Poppins"/>
                       <a:ea typeface="Poppins"/>
@@ -14116,7 +14116,7 @@
                   <a:r>
                     <a:rPr b="0" i="0" lang="en-US" sz="900" u="none" cap="none" strike="noStrike">
                       <a:solidFill>
-                        <a:srgbClr val="BFBFBF"/>
+                        <a:srgbClr val="0D1B2E"/>
                       </a:solidFill>
                       <a:latin typeface="Poppins"/>
                       <a:ea typeface="Poppins"/>
@@ -14508,7 +14508,7 @@
                   <a:r>
                     <a:rPr b="0" i="0" lang="en-US" sz="900" u="none" cap="none" strike="noStrike">
                       <a:solidFill>
-                        <a:srgbClr val="BFBFBF"/>
+                        <a:srgbClr val="0D1B2E"/>
                       </a:solidFill>
                       <a:latin typeface="Poppins"/>
                       <a:ea typeface="Poppins"/>
@@ -14888,7 +14888,7 @@
                   <a:r>
                     <a:rPr b="0" i="0" lang="en-US" sz="900" u="none" cap="none" strike="noStrike">
                       <a:solidFill>
-                        <a:srgbClr val="BFBFBF"/>
+                        <a:srgbClr val="0D1B2E"/>
                       </a:solidFill>
                       <a:latin typeface="Poppins"/>
                       <a:ea typeface="Poppins"/>

</xml_diff>